<commit_message>
docs: improve project status report layout
Co-authored-by: 程序员鱼皮 <592789970@qq.com>
</commit_message>
<xml_diff>
--- a/docs/reports/project-status-2026-07-21.pptx
+++ b/docs/reports/project-status-2026-07-21.pptx
@@ -1749,7 +1749,7 @@
             <a:avLst/>
           </a:prstGeom>
           <a:solidFill>
-            <a:srgbClr val="000000">
+            <a:srgbClr val="21295C">
               <a:alpha val="0"/>
             </a:srgbClr>
           </a:solidFill>
@@ -2084,9 +2084,9 @@
               <a:buNone/>
             </a:pPr>
             <a:r>
-              <a:rPr lang="en-US" sz="1500" dirty="0">
-                <a:solidFill>
-                  <a:srgbClr val="D7F3F5"/>
+              <a:rPr lang="en-US" sz="1600" b="1" dirty="0">
+                <a:solidFill>
+                  <a:srgbClr val="FFFFFF"/>
                 </a:solidFill>
                 <a:latin typeface="Noto Sans CJK SC" pitchFamily="34" charset="0"/>
                 <a:ea typeface="Noto Sans CJK SC" pitchFamily="34" charset="-122"/>
@@ -2094,16 +2094,16 @@
               </a:rPr>
               <a:t>以单体主链路为当前基线</a:t>
             </a:r>
-            <a:endParaRPr lang="en-US" sz="1500" dirty="0"/>
+            <a:endParaRPr lang="en-US" sz="1600" dirty="0"/>
           </a:p>
           <a:p>
             <a:pPr algn="ctr" indent="0" marL="0">
               <a:buNone/>
             </a:pPr>
             <a:r>
-              <a:rPr lang="en-US" sz="1500" dirty="0">
-                <a:solidFill>
-                  <a:srgbClr val="D7F3F5"/>
+              <a:rPr lang="en-US" sz="1600" b="1" dirty="0">
+                <a:solidFill>
+                  <a:srgbClr val="FFFFFF"/>
                 </a:solidFill>
                 <a:latin typeface="Noto Sans CJK SC" pitchFamily="34" charset="0"/>
                 <a:ea typeface="Noto Sans CJK SC" pitchFamily="34" charset="-122"/>
@@ -2111,7 +2111,7 @@
               </a:rPr>
               <a:t>微服务与工作流处于能力迁移阶段</a:t>
             </a:r>
-            <a:endParaRPr lang="en-US" sz="1500" dirty="0"/>
+            <a:endParaRPr lang="en-US" sz="1600" dirty="0"/>
           </a:p>
         </p:txBody>
       </p:sp>
@@ -2220,7 +2220,7 @@
             <a:avLst/>
           </a:prstGeom>
           <a:solidFill>
-            <a:srgbClr val="000000">
+            <a:srgbClr val="21295C">
               <a:alpha val="0"/>
             </a:srgbClr>
           </a:solidFill>
@@ -3967,7 +3967,7 @@
                 <a:ea typeface="Noto Sans CJK SC" pitchFamily="34" charset="-122"/>
                 <a:cs typeface="Noto Sans CJK SC" pitchFamily="34" charset="-120"/>
               </a:rPr>
-              <a:t>微服务已完成 user / app / screenshot 拆分，前端仍默认指向单体 8123</a:t>
+              <a:t>前端仍连接单体 8123；微服务已完成 user / app / screenshot 拆分</a:t>
             </a:r>
             <a:endParaRPr lang="en-US" sz="1500" dirty="0"/>
           </a:p>
@@ -4781,24 +4781,25 @@
         </p:nvSpPr>
         <p:spPr>
           <a:xfrm>
-            <a:off x="1005840" y="2807208"/>
-            <a:ext cx="1371600" cy="1938528"/>
-          </a:xfrm>
-          <a:prstGeom prst="rect">
-            <a:avLst/>
-          </a:prstGeom>
-          <a:noFill/>
-          <a:ln/>
-        </p:spPr>
-        <p:txBody>
-          <a:bodyPr wrap="square" lIns="635" tIns="635" rIns="635" bIns="635" rtlCol="0" anchor="ctr"/>
-          <a:lstStyle/>
-          <a:p>
-            <a:pPr algn="ctr" indent="0" marL="0">
-              <a:buNone/>
-            </a:pPr>
-            <a:r>
-              <a:rPr lang="en-US" sz="1500" dirty="0">
+            <a:off x="1024128" y="2724912"/>
+            <a:ext cx="1325880" cy="2249424"/>
+          </a:xfrm>
+          <a:prstGeom prst="rect">
+            <a:avLst/>
+          </a:prstGeom>
+          <a:noFill/>
+          <a:ln/>
+        </p:spPr>
+        <p:txBody>
+          <a:bodyPr wrap="square" lIns="1016" tIns="1016" rIns="1016" bIns="1016" rtlCol="0" anchor="ctr"/>
+          <a:lstStyle/>
+          <a:p>
+            <a:pPr marL="177800" indent="-177800">
+              <a:buSzPct val="100000"/>
+              <a:buChar char="•"/>
+            </a:pPr>
+            <a:r>
+              <a:rPr lang="en-US" sz="1300" dirty="0">
                 <a:solidFill>
                   <a:srgbClr val="18324A"/>
                 </a:solidFill>
@@ -4808,14 +4809,15 @@
               </a:rPr>
               <a:t>创建应用</a:t>
             </a:r>
-            <a:endParaRPr lang="en-US" sz="1500" dirty="0"/>
-          </a:p>
-          <a:p>
-            <a:pPr algn="ctr" indent="0" marL="0">
-              <a:buNone/>
-            </a:pPr>
-            <a:r>
-              <a:rPr lang="en-US" sz="1500" dirty="0">
+            <a:endParaRPr lang="en-US" sz="1300" dirty="0"/>
+          </a:p>
+          <a:p>
+            <a:pPr marL="177800" indent="-177800">
+              <a:buSzPct val="100000"/>
+              <a:buChar char="•"/>
+            </a:pPr>
+            <a:r>
+              <a:rPr lang="en-US" sz="1300" dirty="0">
                 <a:solidFill>
                   <a:srgbClr val="18324A"/>
                 </a:solidFill>
@@ -4825,14 +4827,15 @@
               </a:rPr>
               <a:t>SSE 对话</a:t>
             </a:r>
-            <a:endParaRPr lang="en-US" sz="1500" dirty="0"/>
-          </a:p>
-          <a:p>
-            <a:pPr algn="ctr" indent="0" marL="0">
-              <a:buNone/>
-            </a:pPr>
-            <a:r>
-              <a:rPr lang="en-US" sz="1500" dirty="0">
+            <a:endParaRPr lang="en-US" sz="1300" dirty="0"/>
+          </a:p>
+          <a:p>
+            <a:pPr marL="177800" indent="-177800">
+              <a:buSzPct val="100000"/>
+              <a:buChar char="•"/>
+            </a:pPr>
+            <a:r>
+              <a:rPr lang="en-US" sz="1300" dirty="0">
                 <a:solidFill>
                   <a:srgbClr val="18324A"/>
                 </a:solidFill>
@@ -4842,14 +4845,15 @@
               </a:rPr>
               <a:t>实时预览</a:t>
             </a:r>
-            <a:endParaRPr lang="en-US" sz="1500" dirty="0"/>
-          </a:p>
-          <a:p>
-            <a:pPr algn="ctr" indent="0" marL="0">
-              <a:buNone/>
-            </a:pPr>
-            <a:r>
-              <a:rPr lang="en-US" sz="1500" dirty="0">
+            <a:endParaRPr lang="en-US" sz="1300" dirty="0"/>
+          </a:p>
+          <a:p>
+            <a:pPr marL="177800" indent="-177800">
+              <a:buSzPct val="100000"/>
+              <a:buChar char="•"/>
+            </a:pPr>
+            <a:r>
+              <a:rPr lang="en-US" sz="1300" dirty="0">
                 <a:solidFill>
                   <a:srgbClr val="18324A"/>
                 </a:solidFill>
@@ -4859,14 +4863,15 @@
               </a:rPr>
               <a:t>可视化编辑</a:t>
             </a:r>
-            <a:endParaRPr lang="en-US" sz="1500" dirty="0"/>
-          </a:p>
-          <a:p>
-            <a:pPr algn="ctr" indent="0" marL="0">
-              <a:buNone/>
-            </a:pPr>
-            <a:r>
-              <a:rPr lang="en-US" sz="1500" dirty="0">
+            <a:endParaRPr lang="en-US" sz="1300" dirty="0"/>
+          </a:p>
+          <a:p>
+            <a:pPr marL="177800" indent="-177800">
+              <a:buSzPct val="100000"/>
+              <a:buChar char="•"/>
+            </a:pPr>
+            <a:r>
+              <a:rPr lang="en-US" sz="1300" dirty="0">
                 <a:solidFill>
                   <a:srgbClr val="18324A"/>
                 </a:solidFill>
@@ -4876,14 +4881,15 @@
               </a:rPr>
               <a:t>部署 / 下载</a:t>
             </a:r>
-            <a:endParaRPr lang="en-US" sz="1500" dirty="0"/>
-          </a:p>
-          <a:p>
-            <a:pPr algn="ctr" indent="0" marL="0">
-              <a:buNone/>
-            </a:pPr>
-            <a:r>
-              <a:rPr lang="en-US" sz="1500" dirty="0">
+            <a:endParaRPr lang="en-US" sz="1300" dirty="0"/>
+          </a:p>
+          <a:p>
+            <a:pPr marL="177800" indent="-177800">
+              <a:buSzPct val="100000"/>
+              <a:buChar char="•"/>
+            </a:pPr>
+            <a:r>
+              <a:rPr lang="en-US" sz="1300" dirty="0">
                 <a:solidFill>
                   <a:srgbClr val="18324A"/>
                 </a:solidFill>
@@ -4893,7 +4899,7 @@
               </a:rPr>
               <a:t>后台管理</a:t>
             </a:r>
-            <a:endParaRPr lang="en-US" sz="1500" dirty="0"/>
+            <a:endParaRPr lang="en-US" sz="1300" dirty="0"/>
           </a:p>
         </p:txBody>
       </p:sp>
@@ -6455,24 +6461,26 @@
         </p:nvSpPr>
         <p:spPr>
           <a:xfrm>
-            <a:off x="1901952" y="2386584"/>
-            <a:ext cx="3611880" cy="566928"/>
-          </a:xfrm>
-          <a:prstGeom prst="rect">
-            <a:avLst/>
-          </a:prstGeom>
-          <a:noFill/>
-          <a:ln/>
-        </p:spPr>
-        <p:txBody>
-          <a:bodyPr wrap="square" lIns="0" tIns="0" rIns="0" bIns="0" rtlCol="0" anchor="ctr"/>
+            <a:off x="1901952" y="2322576"/>
+            <a:ext cx="3611880" cy="786384"/>
+          </a:xfrm>
+          <a:prstGeom prst="rect">
+            <a:avLst/>
+          </a:prstGeom>
+          <a:noFill/>
+          <a:ln/>
+        </p:spPr>
+        <p:txBody>
+          <a:bodyPr wrap="square" lIns="0" tIns="0" rIns="0" bIns="0" rtlCol="0" anchor="ctr">
+            <a:normAutofit/>
+          </a:bodyPr>
           <a:lstStyle/>
           <a:p>
             <a:pPr indent="0" marL="0">
               <a:buNone/>
             </a:pPr>
             <a:r>
-              <a:rPr lang="en-US" sz="1400" dirty="0">
+              <a:rPr lang="en-US" sz="1300" dirty="0">
                 <a:solidFill>
                   <a:srgbClr val="18324A"/>
                 </a:solidFill>
@@ -6482,7 +6490,7 @@
               </a:rPr>
               <a:t>提示词自动路由  ·  SSE 流式过程可见  ·  工具调用生成 Vue 工程</a:t>
             </a:r>
-            <a:endParaRPr lang="en-US" sz="1400" dirty="0"/>
+            <a:endParaRPr lang="en-US" sz="1300" dirty="0"/>
           </a:p>
         </p:txBody>
       </p:sp>
@@ -6662,24 +6670,26 @@
         </p:nvSpPr>
         <p:spPr>
           <a:xfrm>
-            <a:off x="7507224" y="2386584"/>
-            <a:ext cx="3611880" cy="566928"/>
-          </a:xfrm>
-          <a:prstGeom prst="rect">
-            <a:avLst/>
-          </a:prstGeom>
-          <a:noFill/>
-          <a:ln/>
-        </p:spPr>
-        <p:txBody>
-          <a:bodyPr wrap="square" lIns="0" tIns="0" rIns="0" bIns="0" rtlCol="0" anchor="ctr"/>
+            <a:off x="7507224" y="2322576"/>
+            <a:ext cx="3611880" cy="786384"/>
+          </a:xfrm>
+          <a:prstGeom prst="rect">
+            <a:avLst/>
+          </a:prstGeom>
+          <a:noFill/>
+          <a:ln/>
+        </p:spPr>
+        <p:txBody>
+          <a:bodyPr wrap="square" lIns="0" tIns="0" rIns="0" bIns="0" rtlCol="0" anchor="ctr">
+            <a:normAutofit/>
+          </a:bodyPr>
           <a:lstStyle/>
           <a:p>
             <a:pPr indent="0" marL="0">
               <a:buNone/>
             </a:pPr>
             <a:r>
-              <a:rPr lang="en-US" sz="1400" dirty="0">
+              <a:rPr lang="en-US" sz="1300" dirty="0">
                 <a:solidFill>
                   <a:srgbClr val="18324A"/>
                 </a:solidFill>
@@ -6689,7 +6699,7 @@
               </a:rPr>
               <a:t>iframe 实时预览  ·  元素点选与定位  ·  携带上下文再次对话</a:t>
             </a:r>
-            <a:endParaRPr lang="en-US" sz="1400" dirty="0"/>
+            <a:endParaRPr lang="en-US" sz="1300" dirty="0"/>
           </a:p>
         </p:txBody>
       </p:sp>
@@ -6869,24 +6879,26 @@
         </p:nvSpPr>
         <p:spPr>
           <a:xfrm>
-            <a:off x="1901952" y="4645152"/>
-            <a:ext cx="3611880" cy="566928"/>
-          </a:xfrm>
-          <a:prstGeom prst="rect">
-            <a:avLst/>
-          </a:prstGeom>
-          <a:noFill/>
-          <a:ln/>
-        </p:spPr>
-        <p:txBody>
-          <a:bodyPr wrap="square" lIns="0" tIns="0" rIns="0" bIns="0" rtlCol="0" anchor="ctr"/>
+            <a:off x="1901952" y="4581144"/>
+            <a:ext cx="3611880" cy="786384"/>
+          </a:xfrm>
+          <a:prstGeom prst="rect">
+            <a:avLst/>
+          </a:prstGeom>
+          <a:noFill/>
+          <a:ln/>
+        </p:spPr>
+        <p:txBody>
+          <a:bodyPr wrap="square" lIns="0" tIns="0" rIns="0" bIns="0" rtlCol="0" anchor="ctr">
+            <a:normAutofit/>
+          </a:bodyPr>
           <a:lstStyle/>
           <a:p>
             <a:pPr indent="0" marL="0">
               <a:buNone/>
             </a:pPr>
             <a:r>
-              <a:rPr lang="en-US" sz="1400" dirty="0">
+              <a:rPr lang="en-US" sz="1300" dirty="0">
                 <a:solidFill>
                   <a:srgbClr val="18324A"/>
                 </a:solidFill>
@@ -6896,7 +6908,7 @@
               </a:rPr>
               <a:t>本地部署目录映射  ·  Selenium 自动截图  ·  COS 封面与源码 ZIP</a:t>
             </a:r>
-            <a:endParaRPr lang="en-US" sz="1400" dirty="0"/>
+            <a:endParaRPr lang="en-US" sz="1300" dirty="0"/>
           </a:p>
         </p:txBody>
       </p:sp>
@@ -7076,24 +7088,26 @@
         </p:nvSpPr>
         <p:spPr>
           <a:xfrm>
-            <a:off x="7507224" y="4645152"/>
-            <a:ext cx="3611880" cy="566928"/>
-          </a:xfrm>
-          <a:prstGeom prst="rect">
-            <a:avLst/>
-          </a:prstGeom>
-          <a:noFill/>
-          <a:ln/>
-        </p:spPr>
-        <p:txBody>
-          <a:bodyPr wrap="square" lIns="0" tIns="0" rIns="0" bIns="0" rtlCol="0" anchor="ctr"/>
+            <a:off x="7507224" y="4581144"/>
+            <a:ext cx="3611880" cy="786384"/>
+          </a:xfrm>
+          <a:prstGeom prst="rect">
+            <a:avLst/>
+          </a:prstGeom>
+          <a:noFill/>
+          <a:ln/>
+        </p:spPr>
+        <p:txBody>
+          <a:bodyPr wrap="square" lIns="0" tIns="0" rIns="0" bIns="0" rtlCol="0" anchor="ctr">
+            <a:normAutofit/>
+          </a:bodyPr>
           <a:lstStyle/>
           <a:p>
             <a:pPr indent="0" marL="0">
               <a:buNone/>
             </a:pPr>
             <a:r>
-              <a:rPr lang="en-US" sz="1400" dirty="0">
+              <a:rPr lang="en-US" sz="1300" dirty="0">
                 <a:solidFill>
                   <a:srgbClr val="18324A"/>
                 </a:solidFill>
@@ -7103,7 +7117,7 @@
               </a:rPr>
               <a:t>用户 / 应用 / 对话管理  ·  精选应用运营  ·  权限、限流与指标采集</a:t>
             </a:r>
-            <a:endParaRPr lang="en-US" sz="1400" dirty="0"/>
+            <a:endParaRPr lang="en-US" sz="1300" dirty="0"/>
           </a:p>
         </p:txBody>
       </p:sp>

</xml_diff>

<commit_message>
docs: clarify capability card details
Co-authored-by: 程序员鱼皮 <592789970@qq.com>
</commit_message>
<xml_diff>
--- a/docs/reports/project-status-2026-07-21.pptx
+++ b/docs/reports/project-status-2026-07-21.pptx
@@ -6455,14 +6455,41 @@
       </p:sp>
       <p:sp>
         <p:nvSpPr>
-          <p:cNvPr id="13" name="Text 11"/>
-          <p:cNvSpPr/>
-          <p:nvPr/>
-        </p:nvSpPr>
-        <p:spPr>
-          <a:xfrm>
-            <a:off x="1901952" y="2322576"/>
-            <a:ext cx="3611880" cy="786384"/>
+          <p:cNvPr id="13" name="Shape 11"/>
+          <p:cNvSpPr/>
+          <p:nvPr/>
+        </p:nvSpPr>
+        <p:spPr>
+          <a:xfrm>
+            <a:off x="1901952" y="2386584"/>
+            <a:ext cx="91440" cy="91440"/>
+          </a:xfrm>
+          <a:prstGeom prst="ellipse">
+            <a:avLst/>
+          </a:prstGeom>
+          <a:solidFill>
+            <a:srgbClr val="065A82"/>
+          </a:solidFill>
+          <a:ln w="12700">
+            <a:solidFill>
+              <a:srgbClr val="333333">
+                <a:alpha val="0"/>
+              </a:srgbClr>
+            </a:solidFill>
+            <a:prstDash val="solid"/>
+          </a:ln>
+        </p:spPr>
+      </p:sp>
+      <p:sp>
+        <p:nvSpPr>
+          <p:cNvPr id="14" name="Text 12"/>
+          <p:cNvSpPr/>
+          <p:nvPr/>
+        </p:nvSpPr>
+        <p:spPr>
+          <a:xfrm>
+            <a:off x="2130552" y="2340864"/>
+            <a:ext cx="3310128" cy="201168"/>
           </a:xfrm>
           <a:prstGeom prst="rect">
             <a:avLst/>
@@ -6480,7 +6507,7 @@
               <a:buNone/>
             </a:pPr>
             <a:r>
-              <a:rPr lang="en-US" sz="1300" dirty="0">
+              <a:rPr lang="en-US" sz="1250" dirty="0">
                 <a:solidFill>
                   <a:srgbClr val="18324A"/>
                 </a:solidFill>
@@ -6488,15 +6515,151 @@
                 <a:ea typeface="Noto Sans CJK SC" pitchFamily="34" charset="-122"/>
                 <a:cs typeface="Noto Sans CJK SC" pitchFamily="34" charset="-120"/>
               </a:rPr>
-              <a:t>提示词自动路由  ·  SSE 流式过程可见  ·  工具调用生成 Vue 工程</a:t>
-            </a:r>
-            <a:endParaRPr lang="en-US" sz="1300" dirty="0"/>
-          </a:p>
-        </p:txBody>
-      </p:sp>
-      <p:sp>
-        <p:nvSpPr>
-          <p:cNvPr id="14" name="Shape 12"/>
+              <a:t>提示词自动路由</a:t>
+            </a:r>
+            <a:endParaRPr lang="en-US" sz="1250" dirty="0"/>
+          </a:p>
+        </p:txBody>
+      </p:sp>
+      <p:sp>
+        <p:nvSpPr>
+          <p:cNvPr id="15" name="Shape 13"/>
+          <p:cNvSpPr/>
+          <p:nvPr/>
+        </p:nvSpPr>
+        <p:spPr>
+          <a:xfrm>
+            <a:off x="1901952" y="2651760"/>
+            <a:ext cx="91440" cy="91440"/>
+          </a:xfrm>
+          <a:prstGeom prst="ellipse">
+            <a:avLst/>
+          </a:prstGeom>
+          <a:solidFill>
+            <a:srgbClr val="065A82"/>
+          </a:solidFill>
+          <a:ln w="12700">
+            <a:solidFill>
+              <a:srgbClr val="333333">
+                <a:alpha val="0"/>
+              </a:srgbClr>
+            </a:solidFill>
+            <a:prstDash val="solid"/>
+          </a:ln>
+        </p:spPr>
+      </p:sp>
+      <p:sp>
+        <p:nvSpPr>
+          <p:cNvPr id="16" name="Text 14"/>
+          <p:cNvSpPr/>
+          <p:nvPr/>
+        </p:nvSpPr>
+        <p:spPr>
+          <a:xfrm>
+            <a:off x="2130552" y="2606040"/>
+            <a:ext cx="3310128" cy="201168"/>
+          </a:xfrm>
+          <a:prstGeom prst="rect">
+            <a:avLst/>
+          </a:prstGeom>
+          <a:noFill/>
+          <a:ln/>
+        </p:spPr>
+        <p:txBody>
+          <a:bodyPr wrap="square" lIns="0" tIns="0" rIns="0" bIns="0" rtlCol="0" anchor="ctr">
+            <a:normAutofit/>
+          </a:bodyPr>
+          <a:lstStyle/>
+          <a:p>
+            <a:pPr indent="0" marL="0">
+              <a:buNone/>
+            </a:pPr>
+            <a:r>
+              <a:rPr lang="en-US" sz="1250" dirty="0">
+                <a:solidFill>
+                  <a:srgbClr val="18324A"/>
+                </a:solidFill>
+                <a:latin typeface="Noto Sans CJK SC" pitchFamily="34" charset="0"/>
+                <a:ea typeface="Noto Sans CJK SC" pitchFamily="34" charset="-122"/>
+                <a:cs typeface="Noto Sans CJK SC" pitchFamily="34" charset="-120"/>
+              </a:rPr>
+              <a:t>SSE 流式过程可见</a:t>
+            </a:r>
+            <a:endParaRPr lang="en-US" sz="1250" dirty="0"/>
+          </a:p>
+        </p:txBody>
+      </p:sp>
+      <p:sp>
+        <p:nvSpPr>
+          <p:cNvPr id="17" name="Shape 15"/>
+          <p:cNvSpPr/>
+          <p:nvPr/>
+        </p:nvSpPr>
+        <p:spPr>
+          <a:xfrm>
+            <a:off x="1901952" y="2916936"/>
+            <a:ext cx="91440" cy="91440"/>
+          </a:xfrm>
+          <a:prstGeom prst="ellipse">
+            <a:avLst/>
+          </a:prstGeom>
+          <a:solidFill>
+            <a:srgbClr val="065A82"/>
+          </a:solidFill>
+          <a:ln w="12700">
+            <a:solidFill>
+              <a:srgbClr val="333333">
+                <a:alpha val="0"/>
+              </a:srgbClr>
+            </a:solidFill>
+            <a:prstDash val="solid"/>
+          </a:ln>
+        </p:spPr>
+      </p:sp>
+      <p:sp>
+        <p:nvSpPr>
+          <p:cNvPr id="18" name="Text 16"/>
+          <p:cNvSpPr/>
+          <p:nvPr/>
+        </p:nvSpPr>
+        <p:spPr>
+          <a:xfrm>
+            <a:off x="2130552" y="2871216"/>
+            <a:ext cx="3310128" cy="201168"/>
+          </a:xfrm>
+          <a:prstGeom prst="rect">
+            <a:avLst/>
+          </a:prstGeom>
+          <a:noFill/>
+          <a:ln/>
+        </p:spPr>
+        <p:txBody>
+          <a:bodyPr wrap="square" lIns="0" tIns="0" rIns="0" bIns="0" rtlCol="0" anchor="ctr">
+            <a:normAutofit/>
+          </a:bodyPr>
+          <a:lstStyle/>
+          <a:p>
+            <a:pPr indent="0" marL="0">
+              <a:buNone/>
+            </a:pPr>
+            <a:r>
+              <a:rPr lang="en-US" sz="1250" dirty="0">
+                <a:solidFill>
+                  <a:srgbClr val="18324A"/>
+                </a:solidFill>
+                <a:latin typeface="Noto Sans CJK SC" pitchFamily="34" charset="0"/>
+                <a:ea typeface="Noto Sans CJK SC" pitchFamily="34" charset="-122"/>
+                <a:cs typeface="Noto Sans CJK SC" pitchFamily="34" charset="-120"/>
+              </a:rPr>
+              <a:t>工具调用生成 Vue 工程</a:t>
+            </a:r>
+            <a:endParaRPr lang="en-US" sz="1250" dirty="0"/>
+          </a:p>
+        </p:txBody>
+      </p:sp>
+      <p:sp>
+        <p:nvSpPr>
+          <p:cNvPr id="19" name="Shape 17"/>
           <p:cNvSpPr/>
           <p:nvPr/>
         </p:nvSpPr>
@@ -6530,7 +6693,7 @@
       </p:sp>
       <p:sp>
         <p:nvSpPr>
-          <p:cNvPr id="15" name="Shape 13"/>
+          <p:cNvPr id="20" name="Shape 18"/>
           <p:cNvSpPr/>
           <p:nvPr/>
         </p:nvSpPr>
@@ -6559,7 +6722,7 @@
       </p:sp>
       <p:sp>
         <p:nvSpPr>
-          <p:cNvPr id="16" name="Shape 14"/>
+          <p:cNvPr id="21" name="Shape 19"/>
           <p:cNvSpPr/>
           <p:nvPr/>
         </p:nvSpPr>
@@ -6586,7 +6749,7 @@
       </p:sp>
       <p:sp>
         <p:nvSpPr>
-          <p:cNvPr id="17" name="Text 15"/>
+          <p:cNvPr id="22" name="Text 20"/>
           <p:cNvSpPr/>
           <p:nvPr/>
         </p:nvSpPr>
@@ -6625,7 +6788,7 @@
       </p:sp>
       <p:sp>
         <p:nvSpPr>
-          <p:cNvPr id="18" name="Text 16"/>
+          <p:cNvPr id="23" name="Text 21"/>
           <p:cNvSpPr/>
           <p:nvPr/>
         </p:nvSpPr>
@@ -6664,14 +6827,41 @@
       </p:sp>
       <p:sp>
         <p:nvSpPr>
-          <p:cNvPr id="19" name="Text 17"/>
-          <p:cNvSpPr/>
-          <p:nvPr/>
-        </p:nvSpPr>
-        <p:spPr>
-          <a:xfrm>
-            <a:off x="7507224" y="2322576"/>
-            <a:ext cx="3611880" cy="786384"/>
+          <p:cNvPr id="24" name="Shape 22"/>
+          <p:cNvSpPr/>
+          <p:nvPr/>
+        </p:nvSpPr>
+        <p:spPr>
+          <a:xfrm>
+            <a:off x="7507224" y="2386584"/>
+            <a:ext cx="91440" cy="91440"/>
+          </a:xfrm>
+          <a:prstGeom prst="ellipse">
+            <a:avLst/>
+          </a:prstGeom>
+          <a:solidFill>
+            <a:srgbClr val="1C7293"/>
+          </a:solidFill>
+          <a:ln w="12700">
+            <a:solidFill>
+              <a:srgbClr val="333333">
+                <a:alpha val="0"/>
+              </a:srgbClr>
+            </a:solidFill>
+            <a:prstDash val="solid"/>
+          </a:ln>
+        </p:spPr>
+      </p:sp>
+      <p:sp>
+        <p:nvSpPr>
+          <p:cNvPr id="25" name="Text 23"/>
+          <p:cNvSpPr/>
+          <p:nvPr/>
+        </p:nvSpPr>
+        <p:spPr>
+          <a:xfrm>
+            <a:off x="7735824" y="2340864"/>
+            <a:ext cx="3310128" cy="201168"/>
           </a:xfrm>
           <a:prstGeom prst="rect">
             <a:avLst/>
@@ -6689,7 +6879,7 @@
               <a:buNone/>
             </a:pPr>
             <a:r>
-              <a:rPr lang="en-US" sz="1300" dirty="0">
+              <a:rPr lang="en-US" sz="1250" dirty="0">
                 <a:solidFill>
                   <a:srgbClr val="18324A"/>
                 </a:solidFill>
@@ -6697,15 +6887,151 @@
                 <a:ea typeface="Noto Sans CJK SC" pitchFamily="34" charset="-122"/>
                 <a:cs typeface="Noto Sans CJK SC" pitchFamily="34" charset="-120"/>
               </a:rPr>
-              <a:t>iframe 实时预览  ·  元素点选与定位  ·  携带上下文再次对话</a:t>
-            </a:r>
-            <a:endParaRPr lang="en-US" sz="1300" dirty="0"/>
-          </a:p>
-        </p:txBody>
-      </p:sp>
-      <p:sp>
-        <p:nvSpPr>
-          <p:cNvPr id="20" name="Shape 18"/>
+              <a:t>iframe 实时预览</a:t>
+            </a:r>
+            <a:endParaRPr lang="en-US" sz="1250" dirty="0"/>
+          </a:p>
+        </p:txBody>
+      </p:sp>
+      <p:sp>
+        <p:nvSpPr>
+          <p:cNvPr id="26" name="Shape 24"/>
+          <p:cNvSpPr/>
+          <p:nvPr/>
+        </p:nvSpPr>
+        <p:spPr>
+          <a:xfrm>
+            <a:off x="7507224" y="2651760"/>
+            <a:ext cx="91440" cy="91440"/>
+          </a:xfrm>
+          <a:prstGeom prst="ellipse">
+            <a:avLst/>
+          </a:prstGeom>
+          <a:solidFill>
+            <a:srgbClr val="1C7293"/>
+          </a:solidFill>
+          <a:ln w="12700">
+            <a:solidFill>
+              <a:srgbClr val="333333">
+                <a:alpha val="0"/>
+              </a:srgbClr>
+            </a:solidFill>
+            <a:prstDash val="solid"/>
+          </a:ln>
+        </p:spPr>
+      </p:sp>
+      <p:sp>
+        <p:nvSpPr>
+          <p:cNvPr id="27" name="Text 25"/>
+          <p:cNvSpPr/>
+          <p:nvPr/>
+        </p:nvSpPr>
+        <p:spPr>
+          <a:xfrm>
+            <a:off x="7735824" y="2606040"/>
+            <a:ext cx="3310128" cy="201168"/>
+          </a:xfrm>
+          <a:prstGeom prst="rect">
+            <a:avLst/>
+          </a:prstGeom>
+          <a:noFill/>
+          <a:ln/>
+        </p:spPr>
+        <p:txBody>
+          <a:bodyPr wrap="square" lIns="0" tIns="0" rIns="0" bIns="0" rtlCol="0" anchor="ctr">
+            <a:normAutofit/>
+          </a:bodyPr>
+          <a:lstStyle/>
+          <a:p>
+            <a:pPr indent="0" marL="0">
+              <a:buNone/>
+            </a:pPr>
+            <a:r>
+              <a:rPr lang="en-US" sz="1250" dirty="0">
+                <a:solidFill>
+                  <a:srgbClr val="18324A"/>
+                </a:solidFill>
+                <a:latin typeface="Noto Sans CJK SC" pitchFamily="34" charset="0"/>
+                <a:ea typeface="Noto Sans CJK SC" pitchFamily="34" charset="-122"/>
+                <a:cs typeface="Noto Sans CJK SC" pitchFamily="34" charset="-120"/>
+              </a:rPr>
+              <a:t>元素点选与定位</a:t>
+            </a:r>
+            <a:endParaRPr lang="en-US" sz="1250" dirty="0"/>
+          </a:p>
+        </p:txBody>
+      </p:sp>
+      <p:sp>
+        <p:nvSpPr>
+          <p:cNvPr id="28" name="Shape 26"/>
+          <p:cNvSpPr/>
+          <p:nvPr/>
+        </p:nvSpPr>
+        <p:spPr>
+          <a:xfrm>
+            <a:off x="7507224" y="2916936"/>
+            <a:ext cx="91440" cy="91440"/>
+          </a:xfrm>
+          <a:prstGeom prst="ellipse">
+            <a:avLst/>
+          </a:prstGeom>
+          <a:solidFill>
+            <a:srgbClr val="1C7293"/>
+          </a:solidFill>
+          <a:ln w="12700">
+            <a:solidFill>
+              <a:srgbClr val="333333">
+                <a:alpha val="0"/>
+              </a:srgbClr>
+            </a:solidFill>
+            <a:prstDash val="solid"/>
+          </a:ln>
+        </p:spPr>
+      </p:sp>
+      <p:sp>
+        <p:nvSpPr>
+          <p:cNvPr id="29" name="Text 27"/>
+          <p:cNvSpPr/>
+          <p:nvPr/>
+        </p:nvSpPr>
+        <p:spPr>
+          <a:xfrm>
+            <a:off x="7735824" y="2871216"/>
+            <a:ext cx="3310128" cy="201168"/>
+          </a:xfrm>
+          <a:prstGeom prst="rect">
+            <a:avLst/>
+          </a:prstGeom>
+          <a:noFill/>
+          <a:ln/>
+        </p:spPr>
+        <p:txBody>
+          <a:bodyPr wrap="square" lIns="0" tIns="0" rIns="0" bIns="0" rtlCol="0" anchor="ctr">
+            <a:normAutofit/>
+          </a:bodyPr>
+          <a:lstStyle/>
+          <a:p>
+            <a:pPr indent="0" marL="0">
+              <a:buNone/>
+            </a:pPr>
+            <a:r>
+              <a:rPr lang="en-US" sz="1250" dirty="0">
+                <a:solidFill>
+                  <a:srgbClr val="18324A"/>
+                </a:solidFill>
+                <a:latin typeface="Noto Sans CJK SC" pitchFamily="34" charset="0"/>
+                <a:ea typeface="Noto Sans CJK SC" pitchFamily="34" charset="-122"/>
+                <a:cs typeface="Noto Sans CJK SC" pitchFamily="34" charset="-120"/>
+              </a:rPr>
+              <a:t>携带上下文再次对话</a:t>
+            </a:r>
+            <a:endParaRPr lang="en-US" sz="1250" dirty="0"/>
+          </a:p>
+        </p:txBody>
+      </p:sp>
+      <p:sp>
+        <p:nvSpPr>
+          <p:cNvPr id="30" name="Shape 28"/>
           <p:cNvSpPr/>
           <p:nvPr/>
         </p:nvSpPr>
@@ -6739,7 +7065,7 @@
       </p:sp>
       <p:sp>
         <p:nvSpPr>
-          <p:cNvPr id="21" name="Shape 19"/>
+          <p:cNvPr id="31" name="Shape 29"/>
           <p:cNvSpPr/>
           <p:nvPr/>
         </p:nvSpPr>
@@ -6768,7 +7094,7 @@
       </p:sp>
       <p:sp>
         <p:nvSpPr>
-          <p:cNvPr id="22" name="Shape 20"/>
+          <p:cNvPr id="32" name="Shape 30"/>
           <p:cNvSpPr/>
           <p:nvPr/>
         </p:nvSpPr>
@@ -6795,7 +7121,7 @@
       </p:sp>
       <p:sp>
         <p:nvSpPr>
-          <p:cNvPr id="23" name="Text 21"/>
+          <p:cNvPr id="33" name="Text 31"/>
           <p:cNvSpPr/>
           <p:nvPr/>
         </p:nvSpPr>
@@ -6834,7 +7160,7 @@
       </p:sp>
       <p:sp>
         <p:nvSpPr>
-          <p:cNvPr id="24" name="Text 22"/>
+          <p:cNvPr id="34" name="Text 32"/>
           <p:cNvSpPr/>
           <p:nvPr/>
         </p:nvSpPr>
@@ -6873,14 +7199,41 @@
       </p:sp>
       <p:sp>
         <p:nvSpPr>
-          <p:cNvPr id="25" name="Text 23"/>
-          <p:cNvSpPr/>
-          <p:nvPr/>
-        </p:nvSpPr>
-        <p:spPr>
-          <a:xfrm>
-            <a:off x="1901952" y="4581144"/>
-            <a:ext cx="3611880" cy="786384"/>
+          <p:cNvPr id="35" name="Shape 33"/>
+          <p:cNvSpPr/>
+          <p:nvPr/>
+        </p:nvSpPr>
+        <p:spPr>
+          <a:xfrm>
+            <a:off x="1901952" y="4645152"/>
+            <a:ext cx="91440" cy="91440"/>
+          </a:xfrm>
+          <a:prstGeom prst="ellipse">
+            <a:avLst/>
+          </a:prstGeom>
+          <a:solidFill>
+            <a:srgbClr val="00A896"/>
+          </a:solidFill>
+          <a:ln w="12700">
+            <a:solidFill>
+              <a:srgbClr val="333333">
+                <a:alpha val="0"/>
+              </a:srgbClr>
+            </a:solidFill>
+            <a:prstDash val="solid"/>
+          </a:ln>
+        </p:spPr>
+      </p:sp>
+      <p:sp>
+        <p:nvSpPr>
+          <p:cNvPr id="36" name="Text 34"/>
+          <p:cNvSpPr/>
+          <p:nvPr/>
+        </p:nvSpPr>
+        <p:spPr>
+          <a:xfrm>
+            <a:off x="2130552" y="4599432"/>
+            <a:ext cx="3310128" cy="201168"/>
           </a:xfrm>
           <a:prstGeom prst="rect">
             <a:avLst/>
@@ -6898,7 +7251,7 @@
               <a:buNone/>
             </a:pPr>
             <a:r>
-              <a:rPr lang="en-US" sz="1300" dirty="0">
+              <a:rPr lang="en-US" sz="1250" dirty="0">
                 <a:solidFill>
                   <a:srgbClr val="18324A"/>
                 </a:solidFill>
@@ -6906,15 +7259,151 @@
                 <a:ea typeface="Noto Sans CJK SC" pitchFamily="34" charset="-122"/>
                 <a:cs typeface="Noto Sans CJK SC" pitchFamily="34" charset="-120"/>
               </a:rPr>
-              <a:t>本地部署目录映射  ·  Selenium 自动截图  ·  COS 封面与源码 ZIP</a:t>
-            </a:r>
-            <a:endParaRPr lang="en-US" sz="1300" dirty="0"/>
-          </a:p>
-        </p:txBody>
-      </p:sp>
-      <p:sp>
-        <p:nvSpPr>
-          <p:cNvPr id="26" name="Shape 24"/>
+              <a:t>本地部署目录映射</a:t>
+            </a:r>
+            <a:endParaRPr lang="en-US" sz="1250" dirty="0"/>
+          </a:p>
+        </p:txBody>
+      </p:sp>
+      <p:sp>
+        <p:nvSpPr>
+          <p:cNvPr id="37" name="Shape 35"/>
+          <p:cNvSpPr/>
+          <p:nvPr/>
+        </p:nvSpPr>
+        <p:spPr>
+          <a:xfrm>
+            <a:off x="1901952" y="4910328"/>
+            <a:ext cx="91440" cy="91440"/>
+          </a:xfrm>
+          <a:prstGeom prst="ellipse">
+            <a:avLst/>
+          </a:prstGeom>
+          <a:solidFill>
+            <a:srgbClr val="00A896"/>
+          </a:solidFill>
+          <a:ln w="12700">
+            <a:solidFill>
+              <a:srgbClr val="333333">
+                <a:alpha val="0"/>
+              </a:srgbClr>
+            </a:solidFill>
+            <a:prstDash val="solid"/>
+          </a:ln>
+        </p:spPr>
+      </p:sp>
+      <p:sp>
+        <p:nvSpPr>
+          <p:cNvPr id="38" name="Text 36"/>
+          <p:cNvSpPr/>
+          <p:nvPr/>
+        </p:nvSpPr>
+        <p:spPr>
+          <a:xfrm>
+            <a:off x="2130552" y="4864608"/>
+            <a:ext cx="3310128" cy="201168"/>
+          </a:xfrm>
+          <a:prstGeom prst="rect">
+            <a:avLst/>
+          </a:prstGeom>
+          <a:noFill/>
+          <a:ln/>
+        </p:spPr>
+        <p:txBody>
+          <a:bodyPr wrap="square" lIns="0" tIns="0" rIns="0" bIns="0" rtlCol="0" anchor="ctr">
+            <a:normAutofit/>
+          </a:bodyPr>
+          <a:lstStyle/>
+          <a:p>
+            <a:pPr indent="0" marL="0">
+              <a:buNone/>
+            </a:pPr>
+            <a:r>
+              <a:rPr lang="en-US" sz="1250" dirty="0">
+                <a:solidFill>
+                  <a:srgbClr val="18324A"/>
+                </a:solidFill>
+                <a:latin typeface="Noto Sans CJK SC" pitchFamily="34" charset="0"/>
+                <a:ea typeface="Noto Sans CJK SC" pitchFamily="34" charset="-122"/>
+                <a:cs typeface="Noto Sans CJK SC" pitchFamily="34" charset="-120"/>
+              </a:rPr>
+              <a:t>Selenium 自动截图</a:t>
+            </a:r>
+            <a:endParaRPr lang="en-US" sz="1250" dirty="0"/>
+          </a:p>
+        </p:txBody>
+      </p:sp>
+      <p:sp>
+        <p:nvSpPr>
+          <p:cNvPr id="39" name="Shape 37"/>
+          <p:cNvSpPr/>
+          <p:nvPr/>
+        </p:nvSpPr>
+        <p:spPr>
+          <a:xfrm>
+            <a:off x="1901952" y="5175504"/>
+            <a:ext cx="91440" cy="91440"/>
+          </a:xfrm>
+          <a:prstGeom prst="ellipse">
+            <a:avLst/>
+          </a:prstGeom>
+          <a:solidFill>
+            <a:srgbClr val="00A896"/>
+          </a:solidFill>
+          <a:ln w="12700">
+            <a:solidFill>
+              <a:srgbClr val="333333">
+                <a:alpha val="0"/>
+              </a:srgbClr>
+            </a:solidFill>
+            <a:prstDash val="solid"/>
+          </a:ln>
+        </p:spPr>
+      </p:sp>
+      <p:sp>
+        <p:nvSpPr>
+          <p:cNvPr id="40" name="Text 38"/>
+          <p:cNvSpPr/>
+          <p:nvPr/>
+        </p:nvSpPr>
+        <p:spPr>
+          <a:xfrm>
+            <a:off x="2130552" y="5129784"/>
+            <a:ext cx="3310128" cy="201168"/>
+          </a:xfrm>
+          <a:prstGeom prst="rect">
+            <a:avLst/>
+          </a:prstGeom>
+          <a:noFill/>
+          <a:ln/>
+        </p:spPr>
+        <p:txBody>
+          <a:bodyPr wrap="square" lIns="0" tIns="0" rIns="0" bIns="0" rtlCol="0" anchor="ctr">
+            <a:normAutofit/>
+          </a:bodyPr>
+          <a:lstStyle/>
+          <a:p>
+            <a:pPr indent="0" marL="0">
+              <a:buNone/>
+            </a:pPr>
+            <a:r>
+              <a:rPr lang="en-US" sz="1250" dirty="0">
+                <a:solidFill>
+                  <a:srgbClr val="18324A"/>
+                </a:solidFill>
+                <a:latin typeface="Noto Sans CJK SC" pitchFamily="34" charset="0"/>
+                <a:ea typeface="Noto Sans CJK SC" pitchFamily="34" charset="-122"/>
+                <a:cs typeface="Noto Sans CJK SC" pitchFamily="34" charset="-120"/>
+              </a:rPr>
+              <a:t>COS 封面与源码 ZIP</a:t>
+            </a:r>
+            <a:endParaRPr lang="en-US" sz="1250" dirty="0"/>
+          </a:p>
+        </p:txBody>
+      </p:sp>
+      <p:sp>
+        <p:nvSpPr>
+          <p:cNvPr id="41" name="Shape 39"/>
           <p:cNvSpPr/>
           <p:nvPr/>
         </p:nvSpPr>
@@ -6948,7 +7437,7 @@
       </p:sp>
       <p:sp>
         <p:nvSpPr>
-          <p:cNvPr id="27" name="Shape 25"/>
+          <p:cNvPr id="42" name="Shape 40"/>
           <p:cNvSpPr/>
           <p:nvPr/>
         </p:nvSpPr>
@@ -6977,7 +7466,7 @@
       </p:sp>
       <p:sp>
         <p:nvSpPr>
-          <p:cNvPr id="28" name="Shape 26"/>
+          <p:cNvPr id="43" name="Shape 41"/>
           <p:cNvSpPr/>
           <p:nvPr/>
         </p:nvSpPr>
@@ -7004,7 +7493,7 @@
       </p:sp>
       <p:sp>
         <p:nvSpPr>
-          <p:cNvPr id="29" name="Text 27"/>
+          <p:cNvPr id="44" name="Text 42"/>
           <p:cNvSpPr/>
           <p:nvPr/>
         </p:nvSpPr>
@@ -7043,7 +7532,7 @@
       </p:sp>
       <p:sp>
         <p:nvSpPr>
-          <p:cNvPr id="30" name="Text 28"/>
+          <p:cNvPr id="45" name="Text 43"/>
           <p:cNvSpPr/>
           <p:nvPr/>
         </p:nvSpPr>
@@ -7082,14 +7571,41 @@
       </p:sp>
       <p:sp>
         <p:nvSpPr>
-          <p:cNvPr id="31" name="Text 29"/>
-          <p:cNvSpPr/>
-          <p:nvPr/>
-        </p:nvSpPr>
-        <p:spPr>
-          <a:xfrm>
-            <a:off x="7507224" y="4581144"/>
-            <a:ext cx="3611880" cy="786384"/>
+          <p:cNvPr id="46" name="Shape 44"/>
+          <p:cNvSpPr/>
+          <p:nvPr/>
+        </p:nvSpPr>
+        <p:spPr>
+          <a:xfrm>
+            <a:off x="7507224" y="4645152"/>
+            <a:ext cx="91440" cy="91440"/>
+          </a:xfrm>
+          <a:prstGeom prst="ellipse">
+            <a:avLst/>
+          </a:prstGeom>
+          <a:solidFill>
+            <a:srgbClr val="21295C"/>
+          </a:solidFill>
+          <a:ln w="12700">
+            <a:solidFill>
+              <a:srgbClr val="333333">
+                <a:alpha val="0"/>
+              </a:srgbClr>
+            </a:solidFill>
+            <a:prstDash val="solid"/>
+          </a:ln>
+        </p:spPr>
+      </p:sp>
+      <p:sp>
+        <p:nvSpPr>
+          <p:cNvPr id="47" name="Text 45"/>
+          <p:cNvSpPr/>
+          <p:nvPr/>
+        </p:nvSpPr>
+        <p:spPr>
+          <a:xfrm>
+            <a:off x="7735824" y="4599432"/>
+            <a:ext cx="3310128" cy="201168"/>
           </a:xfrm>
           <a:prstGeom prst="rect">
             <a:avLst/>
@@ -7107,7 +7623,7 @@
               <a:buNone/>
             </a:pPr>
             <a:r>
-              <a:rPr lang="en-US" sz="1300" dirty="0">
+              <a:rPr lang="en-US" sz="1250" dirty="0">
                 <a:solidFill>
                   <a:srgbClr val="18324A"/>
                 </a:solidFill>
@@ -7115,15 +7631,151 @@
                 <a:ea typeface="Noto Sans CJK SC" pitchFamily="34" charset="-122"/>
                 <a:cs typeface="Noto Sans CJK SC" pitchFamily="34" charset="-120"/>
               </a:rPr>
-              <a:t>用户 / 应用 / 对话管理  ·  精选应用运营  ·  权限、限流与指标采集</a:t>
-            </a:r>
-            <a:endParaRPr lang="en-US" sz="1300" dirty="0"/>
-          </a:p>
-        </p:txBody>
-      </p:sp>
-      <p:sp>
-        <p:nvSpPr>
-          <p:cNvPr id="32" name="Shape 30"/>
+              <a:t>用户 / 应用 / 对话管理</a:t>
+            </a:r>
+            <a:endParaRPr lang="en-US" sz="1250" dirty="0"/>
+          </a:p>
+        </p:txBody>
+      </p:sp>
+      <p:sp>
+        <p:nvSpPr>
+          <p:cNvPr id="48" name="Shape 46"/>
+          <p:cNvSpPr/>
+          <p:nvPr/>
+        </p:nvSpPr>
+        <p:spPr>
+          <a:xfrm>
+            <a:off x="7507224" y="4910328"/>
+            <a:ext cx="91440" cy="91440"/>
+          </a:xfrm>
+          <a:prstGeom prst="ellipse">
+            <a:avLst/>
+          </a:prstGeom>
+          <a:solidFill>
+            <a:srgbClr val="21295C"/>
+          </a:solidFill>
+          <a:ln w="12700">
+            <a:solidFill>
+              <a:srgbClr val="333333">
+                <a:alpha val="0"/>
+              </a:srgbClr>
+            </a:solidFill>
+            <a:prstDash val="solid"/>
+          </a:ln>
+        </p:spPr>
+      </p:sp>
+      <p:sp>
+        <p:nvSpPr>
+          <p:cNvPr id="49" name="Text 47"/>
+          <p:cNvSpPr/>
+          <p:nvPr/>
+        </p:nvSpPr>
+        <p:spPr>
+          <a:xfrm>
+            <a:off x="7735824" y="4864608"/>
+            <a:ext cx="3310128" cy="201168"/>
+          </a:xfrm>
+          <a:prstGeom prst="rect">
+            <a:avLst/>
+          </a:prstGeom>
+          <a:noFill/>
+          <a:ln/>
+        </p:spPr>
+        <p:txBody>
+          <a:bodyPr wrap="square" lIns="0" tIns="0" rIns="0" bIns="0" rtlCol="0" anchor="ctr">
+            <a:normAutofit/>
+          </a:bodyPr>
+          <a:lstStyle/>
+          <a:p>
+            <a:pPr indent="0" marL="0">
+              <a:buNone/>
+            </a:pPr>
+            <a:r>
+              <a:rPr lang="en-US" sz="1250" dirty="0">
+                <a:solidFill>
+                  <a:srgbClr val="18324A"/>
+                </a:solidFill>
+                <a:latin typeface="Noto Sans CJK SC" pitchFamily="34" charset="0"/>
+                <a:ea typeface="Noto Sans CJK SC" pitchFamily="34" charset="-122"/>
+                <a:cs typeface="Noto Sans CJK SC" pitchFamily="34" charset="-120"/>
+              </a:rPr>
+              <a:t>精选应用运营</a:t>
+            </a:r>
+            <a:endParaRPr lang="en-US" sz="1250" dirty="0"/>
+          </a:p>
+        </p:txBody>
+      </p:sp>
+      <p:sp>
+        <p:nvSpPr>
+          <p:cNvPr id="50" name="Shape 48"/>
+          <p:cNvSpPr/>
+          <p:nvPr/>
+        </p:nvSpPr>
+        <p:spPr>
+          <a:xfrm>
+            <a:off x="7507224" y="5175504"/>
+            <a:ext cx="91440" cy="91440"/>
+          </a:xfrm>
+          <a:prstGeom prst="ellipse">
+            <a:avLst/>
+          </a:prstGeom>
+          <a:solidFill>
+            <a:srgbClr val="21295C"/>
+          </a:solidFill>
+          <a:ln w="12700">
+            <a:solidFill>
+              <a:srgbClr val="333333">
+                <a:alpha val="0"/>
+              </a:srgbClr>
+            </a:solidFill>
+            <a:prstDash val="solid"/>
+          </a:ln>
+        </p:spPr>
+      </p:sp>
+      <p:sp>
+        <p:nvSpPr>
+          <p:cNvPr id="51" name="Text 49"/>
+          <p:cNvSpPr/>
+          <p:nvPr/>
+        </p:nvSpPr>
+        <p:spPr>
+          <a:xfrm>
+            <a:off x="7735824" y="5129784"/>
+            <a:ext cx="3310128" cy="201168"/>
+          </a:xfrm>
+          <a:prstGeom prst="rect">
+            <a:avLst/>
+          </a:prstGeom>
+          <a:noFill/>
+          <a:ln/>
+        </p:spPr>
+        <p:txBody>
+          <a:bodyPr wrap="square" lIns="0" tIns="0" rIns="0" bIns="0" rtlCol="0" anchor="ctr">
+            <a:normAutofit/>
+          </a:bodyPr>
+          <a:lstStyle/>
+          <a:p>
+            <a:pPr indent="0" marL="0">
+              <a:buNone/>
+            </a:pPr>
+            <a:r>
+              <a:rPr lang="en-US" sz="1250" dirty="0">
+                <a:solidFill>
+                  <a:srgbClr val="18324A"/>
+                </a:solidFill>
+                <a:latin typeface="Noto Sans CJK SC" pitchFamily="34" charset="0"/>
+                <a:ea typeface="Noto Sans CJK SC" pitchFamily="34" charset="-122"/>
+                <a:cs typeface="Noto Sans CJK SC" pitchFamily="34" charset="-120"/>
+              </a:rPr>
+              <a:t>权限、限流与指标采集</a:t>
+            </a:r>
+            <a:endParaRPr lang="en-US" sz="1250" dirty="0"/>
+          </a:p>
+        </p:txBody>
+      </p:sp>
+      <p:sp>
+        <p:nvSpPr>
+          <p:cNvPr id="52" name="Shape 50"/>
           <p:cNvSpPr/>
           <p:nvPr/>
         </p:nvSpPr>
@@ -7146,7 +7798,7 @@
       </p:sp>
       <p:sp>
         <p:nvSpPr>
-          <p:cNvPr id="33" name="Text 31"/>
+          <p:cNvPr id="53" name="Text 51"/>
           <p:cNvSpPr/>
           <p:nvPr/>
         </p:nvSpPr>
@@ -7185,7 +7837,7 @@
       </p:sp>
       <p:sp>
         <p:nvSpPr>
-          <p:cNvPr id="34" name="Text 32"/>
+          <p:cNvPr id="54" name="Text 52"/>
           <p:cNvSpPr/>
           <p:nvPr/>
         </p:nvSpPr>

</xml_diff>